<commit_message>
Use 7+ ratings for Week 10 positives
</commit_message>
<xml_diff>
--- a/reports/week10_recommendation_presentation.pptx
+++ b/reports/week10_recommendation_presentation.pptx
@@ -3428,7 +3428,7 @@
               </a:defRPr>
             </a:pPr>
             <a:r>
-              <a:t>Hybrid SVD + popularity beats popularity-only ranking on Hit@10, NDCG@10, and MRR.</a:t>
+              <a:t>Personalized SVD and hybrid ranking both beat popularity-only discovery.</a:t>
             </a:r>
           </a:p>
         </p:txBody>
@@ -4858,7 +4858,7 @@
               </a:defRPr>
             </a:pPr>
             <a:r>
-              <a:t>rating &gt;= 8</a:t>
+              <a:t>rating &gt;= 7</a:t>
             </a:r>
           </a:p>
         </p:txBody>
@@ -5212,7 +5212,7 @@
               </a:defRPr>
             </a:pPr>
             <a:r>
-              <a:t>Hybrid SVD + popularity is the final offline model</a:t>
+              <a:t>Personalized models beat popularity-only discovery</a:t>
             </a:r>
           </a:p>
         </p:txBody>
@@ -5373,7 +5373,7 @@
                         </a:defRPr>
                       </a:pPr>
                       <a:r>
-                        <a:t>hybrid_svd_popularity</a:t>
+                        <a:t>latent_svd</a:t>
                       </a:r>
                     </a:p>
                   </a:txBody>
@@ -5392,7 +5392,7 @@
                         </a:defRPr>
                       </a:pPr>
                       <a:r>
-                        <a:t>0.903</a:t>
+                        <a:t>0.910</a:t>
                       </a:r>
                     </a:p>
                   </a:txBody>
@@ -5411,7 +5411,7 @@
                         </a:defRPr>
                       </a:pPr>
                       <a:r>
-                        <a:t>0.702</a:t>
+                        <a:t>0.716</a:t>
                       </a:r>
                     </a:p>
                   </a:txBody>
@@ -5430,7 +5430,7 @@
                         </a:defRPr>
                       </a:pPr>
                       <a:r>
-                        <a:t>0.642</a:t>
+                        <a:t>0.658</a:t>
                       </a:r>
                     </a:p>
                   </a:txBody>
@@ -5470,7 +5470,7 @@
                         </a:defRPr>
                       </a:pPr>
                       <a:r>
-                        <a:t>latent_svd</a:t>
+                        <a:t>hybrid_svd_popularity</a:t>
                       </a:r>
                     </a:p>
                   </a:txBody>
@@ -5489,7 +5489,7 @@
                         </a:defRPr>
                       </a:pPr>
                       <a:r>
-                        <a:t>0.901</a:t>
+                        <a:t>0.910</a:t>
                       </a:r>
                     </a:p>
                   </a:txBody>
@@ -5508,7 +5508,7 @@
                         </a:defRPr>
                       </a:pPr>
                       <a:r>
-                        <a:t>0.701</a:t>
+                        <a:t>0.716</a:t>
                       </a:r>
                     </a:p>
                   </a:txBody>
@@ -5527,7 +5527,7 @@
                         </a:defRPr>
                       </a:pPr>
                       <a:r>
-                        <a:t>0.642</a:t>
+                        <a:t>0.658</a:t>
                       </a:r>
                     </a:p>
                   </a:txBody>
@@ -5586,7 +5586,7 @@
                         </a:defRPr>
                       </a:pPr>
                       <a:r>
-                        <a:t>0.782</a:t>
+                        <a:t>0.770</a:t>
                       </a:r>
                     </a:p>
                   </a:txBody>
@@ -5605,7 +5605,7 @@
                         </a:defRPr>
                       </a:pPr>
                       <a:r>
-                        <a:t>0.508</a:t>
+                        <a:t>0.501</a:t>
                       </a:r>
                     </a:p>
                   </a:txBody>
@@ -5624,7 +5624,7 @@
                         </a:defRPr>
                       </a:pPr>
                       <a:r>
-                        <a:t>0.435</a:t>
+                        <a:t>0.430</a:t>
                       </a:r>
                     </a:p>
                   </a:txBody>
@@ -5965,7 +5965,7 @@
                         </a:defRPr>
                       </a:pPr>
                       <a:r>
-                        <a:t>5793</a:t>
+                        <a:t>4499</a:t>
                       </a:r>
                     </a:p>
                   </a:txBody>
@@ -5984,7 +5984,7 @@
                         </a:defRPr>
                       </a:pPr>
                       <a:r>
-                        <a:t>24.0</a:t>
+                        <a:t>25.0</a:t>
                       </a:r>
                     </a:p>
                   </a:txBody>
@@ -6003,7 +6003,7 @@
                         </a:defRPr>
                       </a:pPr>
                       <a:r>
-                        <a:t>0.904</a:t>
+                        <a:t>0.913</a:t>
                       </a:r>
                     </a:p>
                   </a:txBody>
@@ -6062,7 +6062,7 @@
                         </a:defRPr>
                       </a:pPr>
                       <a:r>
-                        <a:t>6150</a:t>
+                        <a:t>5575</a:t>
                       </a:r>
                     </a:p>
                   </a:txBody>
@@ -6081,7 +6081,7 @@
                         </a:defRPr>
                       </a:pPr>
                       <a:r>
-                        <a:t>86.0</a:t>
+                        <a:t>90.0</a:t>
                       </a:r>
                     </a:p>
                   </a:txBody>
@@ -6100,7 +6100,7 @@
                         </a:defRPr>
                       </a:pPr>
                       <a:r>
-                        <a:t>0.916</a:t>
+                        <a:t>0.920</a:t>
                       </a:r>
                     </a:p>
                   </a:txBody>
@@ -6159,7 +6159,7 @@
                         </a:defRPr>
                       </a:pPr>
                       <a:r>
-                        <a:t>3039</a:t>
+                        <a:t>4864</a:t>
                       </a:r>
                     </a:p>
                   </a:txBody>
@@ -6178,7 +6178,7 @@
                         </a:defRPr>
                       </a:pPr>
                       <a:r>
-                        <a:t>228.0</a:t>
+                        <a:t>245.0</a:t>
                       </a:r>
                     </a:p>
                   </a:txBody>
@@ -6197,7 +6197,7 @@
                         </a:defRPr>
                       </a:pPr>
                       <a:r>
-                        <a:t>0.877</a:t>
+                        <a:t>0.896</a:t>
                       </a:r>
                     </a:p>
                   </a:txBody>
@@ -6256,7 +6256,7 @@
                         </a:defRPr>
                       </a:pPr>
                       <a:r>
-                        <a:t>18</a:t>
+                        <a:t>62</a:t>
                       </a:r>
                     </a:p>
                   </a:txBody>
@@ -6275,7 +6275,7 @@
                         </a:defRPr>
                       </a:pPr>
                       <a:r>
-                        <a:t>1193.5</a:t>
+                        <a:t>1153.5</a:t>
                       </a:r>
                     </a:p>
                   </a:txBody>
@@ -6294,7 +6294,7 @@
                         </a:defRPr>
                       </a:pPr>
                       <a:r>
-                        <a:t>0.667</a:t>
+                        <a:t>0.806</a:t>
                       </a:r>
                     </a:p>
                   </a:txBody>
@@ -6313,7 +6313,7 @@
                         </a:defRPr>
                       </a:pPr>
                       <a:r>
-                        <a:t>4.5</a:t>
+                        <a:t>3.0</a:t>
                       </a:r>
                     </a:p>
                   </a:txBody>

</xml_diff>